<commit_message>
Give the autumn journal's main visuals an entrance
Six illustration groups on the term pages and the closing seal were
static while the rest of the deck animated: the lead doodle on Liqiu,
Chushu, Bailu, Qiufen and Hanlu now enters first (zoom, float, rise),
the Bailu goose follows its entrance, and the closing seal stamps in
after the six picks. Sidecar and PPTX only; SVGs unchanged.

Co-Authored-By: Claude Fable 5.1 <noreply@anthropic.com>
Claude-Session: https://claude.ai/code/session_012NoFEKH3he3B5mkTi8ZQiE
</commit_message>
<xml_diff>
--- a/examples/story_autumn_solar_terms/exports/story_autumn_solar_terms.pptx
+++ b/examples/story_autumn_solar_terms/exports/story_autumn_solar_terms.pptx
@@ -3294,6 +3294,165 @@
   <p:transition xmlns:p14="http://schemas.microsoft.com/office/powerpoint/2010/main" p14:dur="400">
     <p:fade/>
   </p:transition>
+  <p:timing>
+    <p:tnLst>
+      <p:par>
+        <p:cTn id="1" dur="indefinite" restart="never" nodeType="tmRoot">
+          <p:childTnLst>
+            <p:seq concurrent="1" nextAc="seek">
+              <p:cTn id="2" dur="indefinite" nodeType="mainSeq">
+                <p:childTnLst>
+                  <p:par>
+                    <p:cTn id="3" fill="hold">
+                      <p:stCondLst>
+                        <p:cond delay="indefinite"/>
+                        <p:cond evt="onBegin" delay="0">
+                          <p:tn val="2"/>
+                        </p:cond>
+                      </p:stCondLst>
+                      <p:childTnLst>
+                        <p:par>
+                          <p:cTn id="4" fill="hold">
+                            <p:stCondLst>
+                              <p:cond delay="0"/>
+                            </p:stCondLst>
+                            <p:childTnLst>
+                              <p:par>
+                                <p:cTn xmlns:p="http://schemas.openxmlformats.org/presentationml/2006/main" id="5" presetID="37" presetClass="entr" presetSubtype="0" fill="hold" grpId="0" nodeType="afterEffect">
+                                  <p:stCondLst>
+                                    <p:cond delay="0"/>
+                                  </p:stCondLst>
+                                  <p:childTnLst>
+                                    <p:set>
+                                      <p:cBhvr>
+                                        <p:cTn id="6" dur="1" fill="hold">
+                                          <p:stCondLst>
+                                            <p:cond delay="0"/>
+                                          </p:stCondLst>
+                                        </p:cTn>
+                                        <p:tgtEl>
+                                          <p:spTgt spid="14"/>
+                                        </p:tgtEl>
+                                        <p:attrNameLst>
+                                          <p:attrName>style.visibility</p:attrName>
+                                        </p:attrNameLst>
+                                      </p:cBhvr>
+                                      <p:to>
+                                        <p:strVal val="visible"/>
+                                      </p:to>
+                                    </p:set>
+                                    <p:animEffect transition="in" filter="fade">
+                                      <p:cBhvr>
+                                        <p:cTn id="7" dur="700"/>
+                                        <p:tgtEl>
+                                          <p:spTgt spid="14"/>
+                                        </p:tgtEl>
+                                      </p:cBhvr>
+                                    </p:animEffect>
+                                    <p:anim calcmode="lin" valueType="num">
+                                      <p:cBhvr>
+                                        <p:cTn id="8" dur="700" fill="hold"/>
+                                        <p:tgtEl>
+                                          <p:spTgt spid="14"/>
+                                        </p:tgtEl>
+                                        <p:attrNameLst>
+                                          <p:attrName>ppt_x</p:attrName>
+                                        </p:attrNameLst>
+                                      </p:cBhvr>
+                                      <p:tavLst>
+                                        <p:tav tm="0">
+                                          <p:val>
+                                            <p:strVal val="#ppt_x"/>
+                                          </p:val>
+                                        </p:tav>
+                                        <p:tav tm="100000">
+                                          <p:val>
+                                            <p:strVal val="#ppt_x"/>
+                                          </p:val>
+                                        </p:tav>
+                                      </p:tavLst>
+                                    </p:anim>
+                                    <p:anim calcmode="lin" valueType="num">
+                                      <p:cBhvr>
+                                        <p:cTn id="9" dur="630" decel="100000" fill="hold"/>
+                                        <p:tgtEl>
+                                          <p:spTgt spid="14"/>
+                                        </p:tgtEl>
+                                        <p:attrNameLst>
+                                          <p:attrName>ppt_y</p:attrName>
+                                        </p:attrNameLst>
+                                      </p:cBhvr>
+                                      <p:tavLst>
+                                        <p:tav tm="0">
+                                          <p:val>
+                                            <p:strVal val="#ppt_y+1"/>
+                                          </p:val>
+                                        </p:tav>
+                                        <p:tav tm="100000">
+                                          <p:val>
+                                            <p:strVal val="#ppt_y-.03"/>
+                                          </p:val>
+                                        </p:tav>
+                                      </p:tavLst>
+                                    </p:anim>
+                                    <p:anim calcmode="lin" valueType="num">
+                                      <p:cBhvr>
+                                        <p:cTn id="10" dur="70" accel="100000" fill="hold">
+                                          <p:stCondLst>
+                                            <p:cond delay="630"/>
+                                          </p:stCondLst>
+                                        </p:cTn>
+                                        <p:tgtEl>
+                                          <p:spTgt spid="14"/>
+                                        </p:tgtEl>
+                                        <p:attrNameLst>
+                                          <p:attrName>ppt_y</p:attrName>
+                                        </p:attrNameLst>
+                                      </p:cBhvr>
+                                      <p:tavLst>
+                                        <p:tav tm="0">
+                                          <p:val>
+                                            <p:strVal val="#ppt_y-.03"/>
+                                          </p:val>
+                                        </p:tav>
+                                        <p:tav tm="100000">
+                                          <p:val>
+                                            <p:strVal val="#ppt_y"/>
+                                          </p:val>
+                                        </p:tav>
+                                      </p:tavLst>
+                                    </p:anim>
+                                  </p:childTnLst>
+                                </p:cTn>
+                              </p:par>
+                            </p:childTnLst>
+                          </p:cTn>
+                        </p:par>
+                      </p:childTnLst>
+                    </p:cTn>
+                  </p:par>
+                </p:childTnLst>
+              </p:cTn>
+              <p:prevCondLst>
+                <p:cond evt="onPrev" delay="0">
+                  <p:tgtEl>
+                    <p:sldTgt/>
+                  </p:tgtEl>
+                </p:cond>
+              </p:prevCondLst>
+              <p:nextCondLst>
+                <p:cond evt="onNext" delay="0">
+                  <p:tgtEl>
+                    <p:sldTgt/>
+                  </p:tgtEl>
+                </p:cond>
+              </p:nextCondLst>
+            </p:seq>
+          </p:childTnLst>
+        </p:cTn>
+      </p:par>
+    </p:tnLst>
+  </p:timing>
 </p:sld>
 </file>
 
@@ -7105,6 +7264,88 @@
                                         </p:tgtEl>
                                       </p:cBhvr>
                                     </p:animEffect>
+                                  </p:childTnLst>
+                                </p:cTn>
+                              </p:par>
+                            </p:childTnLst>
+                          </p:cTn>
+                        </p:par>
+                        <p:par>
+                          <p:cTn id="28" fill="hold">
+                            <p:stCondLst>
+                              <p:cond delay="4000"/>
+                            </p:stCondLst>
+                            <p:childTnLst>
+                              <p:par>
+                                <p:cTn xmlns:p="http://schemas.openxmlformats.org/presentationml/2006/main" id="29" presetID="23" presetClass="entr" presetSubtype="16" fill="hold" grpId="0" nodeType="afterEffect">
+                                  <p:stCondLst>
+                                    <p:cond delay="500"/>
+                                  </p:stCondLst>
+                                  <p:childTnLst>
+                                    <p:set>
+                                      <p:cBhvr>
+                                        <p:cTn id="30" dur="1" fill="hold">
+                                          <p:stCondLst>
+                                            <p:cond delay="0"/>
+                                          </p:stCondLst>
+                                        </p:cTn>
+                                        <p:tgtEl>
+                                          <p:spTgt spid="28"/>
+                                        </p:tgtEl>
+                                        <p:attrNameLst>
+                                          <p:attrName>style.visibility</p:attrName>
+                                        </p:attrNameLst>
+                                      </p:cBhvr>
+                                      <p:to>
+                                        <p:strVal val="visible"/>
+                                      </p:to>
+                                    </p:set>
+                                    <p:anim calcmode="lin" valueType="num">
+                                      <p:cBhvr>
+                                        <p:cTn id="31" dur="400" fill="hold"/>
+                                        <p:tgtEl>
+                                          <p:spTgt spid="28"/>
+                                        </p:tgtEl>
+                                        <p:attrNameLst>
+                                          <p:attrName>ppt_w</p:attrName>
+                                        </p:attrNameLst>
+                                      </p:cBhvr>
+                                      <p:tavLst>
+                                        <p:tav tm="0">
+                                          <p:val>
+                                            <p:fltVal val="0"/>
+                                          </p:val>
+                                        </p:tav>
+                                        <p:tav tm="100000">
+                                          <p:val>
+                                            <p:strVal val="#ppt_w"/>
+                                          </p:val>
+                                        </p:tav>
+                                      </p:tavLst>
+                                    </p:anim>
+                                    <p:anim calcmode="lin" valueType="num">
+                                      <p:cBhvr>
+                                        <p:cTn id="32" dur="400" fill="hold"/>
+                                        <p:tgtEl>
+                                          <p:spTgt spid="28"/>
+                                        </p:tgtEl>
+                                        <p:attrNameLst>
+                                          <p:attrName>ppt_h</p:attrName>
+                                        </p:attrNameLst>
+                                      </p:cBhvr>
+                                      <p:tavLst>
+                                        <p:tav tm="0">
+                                          <p:val>
+                                            <p:fltVal val="0"/>
+                                          </p:val>
+                                        </p:tav>
+                                        <p:tav tm="100000">
+                                          <p:val>
+                                            <p:strVal val="#ppt_h"/>
+                                          </p:val>
+                                        </p:tav>
+                                      </p:tavLst>
+                                    </p:anim>
                                   </p:childTnLst>
                                 </p:cTn>
                               </p:par>
@@ -13203,6 +13444,130 @@
       </p:transition>
     </mc:Fallback>
   </mc:AlternateContent>
+  <p:timing>
+    <p:tnLst>
+      <p:par>
+        <p:cTn id="1" dur="indefinite" restart="never" nodeType="tmRoot">
+          <p:childTnLst>
+            <p:seq concurrent="1" nextAc="seek">
+              <p:cTn id="2" dur="indefinite" nodeType="mainSeq">
+                <p:childTnLst>
+                  <p:par>
+                    <p:cTn id="3" fill="hold">
+                      <p:stCondLst>
+                        <p:cond delay="indefinite"/>
+                        <p:cond evt="onBegin" delay="0">
+                          <p:tn val="2"/>
+                        </p:cond>
+                      </p:stCondLst>
+                      <p:childTnLst>
+                        <p:par>
+                          <p:cTn id="4" fill="hold">
+                            <p:stCondLst>
+                              <p:cond delay="0"/>
+                            </p:stCondLst>
+                            <p:childTnLst>
+                              <p:par>
+                                <p:cTn id="5" presetID="23" presetClass="entr" presetSubtype="16" fill="hold" grpId="0" nodeType="afterEffect">
+                                  <p:stCondLst>
+                                    <p:cond delay="0"/>
+                                  </p:stCondLst>
+                                  <p:childTnLst>
+                                    <p:set>
+                                      <p:cBhvr>
+                                        <p:cTn id="6" dur="1" fill="hold">
+                                          <p:stCondLst>
+                                            <p:cond delay="0"/>
+                                          </p:stCondLst>
+                                        </p:cTn>
+                                        <p:tgtEl>
+                                          <p:spTgt spid="21"/>
+                                        </p:tgtEl>
+                                        <p:attrNameLst>
+                                          <p:attrName>style.visibility</p:attrName>
+                                        </p:attrNameLst>
+                                      </p:cBhvr>
+                                      <p:to>
+                                        <p:strVal val="visible"/>
+                                      </p:to>
+                                    </p:set>
+                                    <p:anim calcmode="lin" valueType="num">
+                                      <p:cBhvr>
+                                        <p:cTn id="7" dur="600" fill="hold"/>
+                                        <p:tgtEl>
+                                          <p:spTgt spid="21"/>
+                                        </p:tgtEl>
+                                        <p:attrNameLst>
+                                          <p:attrName>ppt_w</p:attrName>
+                                        </p:attrNameLst>
+                                      </p:cBhvr>
+                                      <p:tavLst>
+                                        <p:tav tm="0">
+                                          <p:val>
+                                            <p:fltVal val="0"/>
+                                          </p:val>
+                                        </p:tav>
+                                        <p:tav tm="100000">
+                                          <p:val>
+                                            <p:strVal val="#ppt_w"/>
+                                          </p:val>
+                                        </p:tav>
+                                      </p:tavLst>
+                                    </p:anim>
+                                    <p:anim calcmode="lin" valueType="num">
+                                      <p:cBhvr>
+                                        <p:cTn id="8" dur="600" fill="hold"/>
+                                        <p:tgtEl>
+                                          <p:spTgt spid="21"/>
+                                        </p:tgtEl>
+                                        <p:attrNameLst>
+                                          <p:attrName>ppt_h</p:attrName>
+                                        </p:attrNameLst>
+                                      </p:cBhvr>
+                                      <p:tavLst>
+                                        <p:tav tm="0">
+                                          <p:val>
+                                            <p:fltVal val="0"/>
+                                          </p:val>
+                                        </p:tav>
+                                        <p:tav tm="100000">
+                                          <p:val>
+                                            <p:strVal val="#ppt_h"/>
+                                          </p:val>
+                                        </p:tav>
+                                      </p:tavLst>
+                                    </p:anim>
+                                  </p:childTnLst>
+                                </p:cTn>
+                              </p:par>
+                            </p:childTnLst>
+                          </p:cTn>
+                        </p:par>
+                      </p:childTnLst>
+                    </p:cTn>
+                  </p:par>
+                </p:childTnLst>
+              </p:cTn>
+              <p:prevCondLst>
+                <p:cond evt="onPrev" delay="0">
+                  <p:tgtEl>
+                    <p:sldTgt/>
+                  </p:tgtEl>
+                </p:cond>
+              </p:prevCondLst>
+              <p:nextCondLst>
+                <p:cond evt="onNext" delay="0">
+                  <p:tgtEl>
+                    <p:sldTgt/>
+                  </p:tgtEl>
+                </p:cond>
+              </p:nextCondLst>
+            </p:seq>
+          </p:childTnLst>
+        </p:cTn>
+      </p:par>
+    </p:tnLst>
+  </p:timing>
 </p:sld>
 </file>
 
@@ -14238,6 +14603,215 @@
   <p:transition xmlns:p14="http://schemas.microsoft.com/office/powerpoint/2010/main" p14:dur="400">
     <p:fade/>
   </p:transition>
+  <p:timing>
+    <p:tnLst>
+      <p:par>
+        <p:cTn id="1" dur="indefinite" restart="never" nodeType="tmRoot">
+          <p:childTnLst>
+            <p:seq concurrent="1" nextAc="seek">
+              <p:cTn id="2" dur="indefinite" nodeType="mainSeq">
+                <p:childTnLst>
+                  <p:par>
+                    <p:cTn id="3" fill="hold">
+                      <p:stCondLst>
+                        <p:cond delay="indefinite"/>
+                        <p:cond evt="onBegin" delay="0">
+                          <p:tn val="2"/>
+                        </p:cond>
+                      </p:stCondLst>
+                      <p:childTnLst>
+                        <p:par>
+                          <p:cTn id="4" fill="hold">
+                            <p:stCondLst>
+                              <p:cond delay="0"/>
+                            </p:stCondLst>
+                            <p:childTnLst>
+                              <p:par>
+                                <p:cTn xmlns:p="http://schemas.openxmlformats.org/presentationml/2006/main" id="5" presetID="30" presetClass="entr" presetSubtype="0" fill="hold" grpId="0" nodeType="afterEffect">
+                                  <p:stCondLst>
+                                    <p:cond delay="0"/>
+                                  </p:stCondLst>
+                                  <p:childTnLst>
+                                    <p:set>
+                                      <p:cBhvr>
+                                        <p:cTn id="6" dur="1" fill="hold">
+                                          <p:stCondLst>
+                                            <p:cond delay="0"/>
+                                          </p:stCondLst>
+                                        </p:cTn>
+                                        <p:tgtEl>
+                                          <p:spTgt spid="25"/>
+                                        </p:tgtEl>
+                                        <p:attrNameLst>
+                                          <p:attrName>style.visibility</p:attrName>
+                                        </p:attrNameLst>
+                                      </p:cBhvr>
+                                      <p:to>
+                                        <p:strVal val="visible"/>
+                                      </p:to>
+                                    </p:set>
+                                    <p:animEffect transition="in" filter="fade">
+                                      <p:cBhvr>
+                                        <p:cTn id="7" dur="480" decel="100000"/>
+                                        <p:tgtEl>
+                                          <p:spTgt spid="25"/>
+                                        </p:tgtEl>
+                                      </p:cBhvr>
+                                    </p:animEffect>
+                                    <p:anim calcmode="lin" valueType="num">
+                                      <p:cBhvr>
+                                        <p:cTn id="8" dur="480" decel="100000" fill="hold"/>
+                                        <p:tgtEl>
+                                          <p:spTgt spid="25"/>
+                                        </p:tgtEl>
+                                        <p:attrNameLst>
+                                          <p:attrName>style.rotation</p:attrName>
+                                        </p:attrNameLst>
+                                      </p:cBhvr>
+                                      <p:tavLst>
+                                        <p:tav tm="0">
+                                          <p:val>
+                                            <p:fltVal val="-90"/>
+                                          </p:val>
+                                        </p:tav>
+                                        <p:tav tm="100000">
+                                          <p:val>
+                                            <p:fltVal val="0"/>
+                                          </p:val>
+                                        </p:tav>
+                                      </p:tavLst>
+                                    </p:anim>
+                                    <p:anim calcmode="lin" valueType="num">
+                                      <p:cBhvr>
+                                        <p:cTn id="9" dur="480" decel="100000" fill="hold"/>
+                                        <p:tgtEl>
+                                          <p:spTgt spid="25"/>
+                                        </p:tgtEl>
+                                        <p:attrNameLst>
+                                          <p:attrName>ppt_x</p:attrName>
+                                        </p:attrNameLst>
+                                      </p:cBhvr>
+                                      <p:tavLst>
+                                        <p:tav tm="0">
+                                          <p:val>
+                                            <p:strVal val="#ppt_x+0.4"/>
+                                          </p:val>
+                                        </p:tav>
+                                        <p:tav tm="100000">
+                                          <p:val>
+                                            <p:strVal val="#ppt_x-0.05"/>
+                                          </p:val>
+                                        </p:tav>
+                                      </p:tavLst>
+                                    </p:anim>
+                                    <p:anim calcmode="lin" valueType="num">
+                                      <p:cBhvr>
+                                        <p:cTn id="10" dur="480" decel="100000" fill="hold"/>
+                                        <p:tgtEl>
+                                          <p:spTgt spid="25"/>
+                                        </p:tgtEl>
+                                        <p:attrNameLst>
+                                          <p:attrName>ppt_y</p:attrName>
+                                        </p:attrNameLst>
+                                      </p:cBhvr>
+                                      <p:tavLst>
+                                        <p:tav tm="0">
+                                          <p:val>
+                                            <p:strVal val="#ppt_y-0.4"/>
+                                          </p:val>
+                                        </p:tav>
+                                        <p:tav tm="100000">
+                                          <p:val>
+                                            <p:strVal val="#ppt_y+0.1"/>
+                                          </p:val>
+                                        </p:tav>
+                                      </p:tavLst>
+                                    </p:anim>
+                                    <p:anim calcmode="lin" valueType="num">
+                                      <p:cBhvr>
+                                        <p:cTn id="11" dur="120" accel="100000" fill="hold">
+                                          <p:stCondLst>
+                                            <p:cond delay="480"/>
+                                          </p:stCondLst>
+                                        </p:cTn>
+                                        <p:tgtEl>
+                                          <p:spTgt spid="25"/>
+                                        </p:tgtEl>
+                                        <p:attrNameLst>
+                                          <p:attrName>ppt_x</p:attrName>
+                                        </p:attrNameLst>
+                                      </p:cBhvr>
+                                      <p:tavLst>
+                                        <p:tav tm="0">
+                                          <p:val>
+                                            <p:strVal val="#ppt_x-0.05"/>
+                                          </p:val>
+                                        </p:tav>
+                                        <p:tav tm="100000">
+                                          <p:val>
+                                            <p:strVal val="#ppt_x"/>
+                                          </p:val>
+                                        </p:tav>
+                                      </p:tavLst>
+                                    </p:anim>
+                                    <p:anim calcmode="lin" valueType="num">
+                                      <p:cBhvr>
+                                        <p:cTn id="12" dur="120" accel="100000" fill="hold">
+                                          <p:stCondLst>
+                                            <p:cond delay="480"/>
+                                          </p:stCondLst>
+                                        </p:cTn>
+                                        <p:tgtEl>
+                                          <p:spTgt spid="25"/>
+                                        </p:tgtEl>
+                                        <p:attrNameLst>
+                                          <p:attrName>ppt_y</p:attrName>
+                                        </p:attrNameLst>
+                                      </p:cBhvr>
+                                      <p:tavLst>
+                                        <p:tav tm="0">
+                                          <p:val>
+                                            <p:strVal val="#ppt_y+0.1"/>
+                                          </p:val>
+                                        </p:tav>
+                                        <p:tav tm="100000">
+                                          <p:val>
+                                            <p:strVal val="#ppt_y"/>
+                                          </p:val>
+                                        </p:tav>
+                                      </p:tavLst>
+                                    </p:anim>
+                                  </p:childTnLst>
+                                </p:cTn>
+                              </p:par>
+                            </p:childTnLst>
+                          </p:cTn>
+                        </p:par>
+                      </p:childTnLst>
+                    </p:cTn>
+                  </p:par>
+                </p:childTnLst>
+              </p:cTn>
+              <p:prevCondLst>
+                <p:cond evt="onPrev" delay="0">
+                  <p:tgtEl>
+                    <p:sldTgt/>
+                  </p:tgtEl>
+                </p:cond>
+              </p:prevCondLst>
+              <p:nextCondLst>
+                <p:cond evt="onNext" delay="0">
+                  <p:tgtEl>
+                    <p:sldTgt/>
+                  </p:tgtEl>
+                </p:cond>
+              </p:nextCondLst>
+            </p:seq>
+          </p:childTnLst>
+        </p:cTn>
+      </p:par>
+    </p:tnLst>
+  </p:timing>
 </p:sld>
 </file>
 
@@ -16435,7 +17009,7 @@
                             </p:stCondLst>
                             <p:childTnLst>
                               <p:par>
-                                <p:cTn xmlns:p="http://schemas.openxmlformats.org/presentationml/2006/main" id="5" presetID="10" presetClass="entr" presetSubtype="0" fill="hold" grpId="0" nodeType="afterEffect">
+                                <p:cTn xmlns:p="http://schemas.openxmlformats.org/presentationml/2006/main" id="5" presetID="23" presetClass="entr" presetSubtype="16" fill="hold" grpId="0" nodeType="afterEffect">
                                   <p:stCondLst>
                                     <p:cond delay="0"/>
                                   </p:stCondLst>
@@ -16443,6 +17017,88 @@
                                     <p:set>
                                       <p:cBhvr>
                                         <p:cTn id="6" dur="1" fill="hold">
+                                          <p:stCondLst>
+                                            <p:cond delay="0"/>
+                                          </p:stCondLst>
+                                        </p:cTn>
+                                        <p:tgtEl>
+                                          <p:spTgt spid="13"/>
+                                        </p:tgtEl>
+                                        <p:attrNameLst>
+                                          <p:attrName>style.visibility</p:attrName>
+                                        </p:attrNameLst>
+                                      </p:cBhvr>
+                                      <p:to>
+                                        <p:strVal val="visible"/>
+                                      </p:to>
+                                    </p:set>
+                                    <p:anim calcmode="lin" valueType="num">
+                                      <p:cBhvr>
+                                        <p:cTn id="7" dur="600" fill="hold"/>
+                                        <p:tgtEl>
+                                          <p:spTgt spid="13"/>
+                                        </p:tgtEl>
+                                        <p:attrNameLst>
+                                          <p:attrName>ppt_w</p:attrName>
+                                        </p:attrNameLst>
+                                      </p:cBhvr>
+                                      <p:tavLst>
+                                        <p:tav tm="0">
+                                          <p:val>
+                                            <p:fltVal val="0"/>
+                                          </p:val>
+                                        </p:tav>
+                                        <p:tav tm="100000">
+                                          <p:val>
+                                            <p:strVal val="#ppt_w"/>
+                                          </p:val>
+                                        </p:tav>
+                                      </p:tavLst>
+                                    </p:anim>
+                                    <p:anim calcmode="lin" valueType="num">
+                                      <p:cBhvr>
+                                        <p:cTn id="8" dur="600" fill="hold"/>
+                                        <p:tgtEl>
+                                          <p:spTgt spid="13"/>
+                                        </p:tgtEl>
+                                        <p:attrNameLst>
+                                          <p:attrName>ppt_h</p:attrName>
+                                        </p:attrNameLst>
+                                      </p:cBhvr>
+                                      <p:tavLst>
+                                        <p:tav tm="0">
+                                          <p:val>
+                                            <p:fltVal val="0"/>
+                                          </p:val>
+                                        </p:tav>
+                                        <p:tav tm="100000">
+                                          <p:val>
+                                            <p:strVal val="#ppt_h"/>
+                                          </p:val>
+                                        </p:tav>
+                                      </p:tavLst>
+                                    </p:anim>
+                                  </p:childTnLst>
+                                </p:cTn>
+                              </p:par>
+                            </p:childTnLst>
+                          </p:cTn>
+                        </p:par>
+                        <p:par>
+                          <p:cTn id="9" fill="hold">
+                            <p:stCondLst>
+                              <p:cond delay="600"/>
+                            </p:stCondLst>
+                            <p:childTnLst>
+                              <p:par>
+                                <p:cTn xmlns:p="http://schemas.openxmlformats.org/presentationml/2006/main" id="10" presetID="10" presetClass="entr" presetSubtype="0" fill="hold" grpId="0" nodeType="afterEffect">
+                                  <p:stCondLst>
+                                    <p:cond delay="500"/>
+                                  </p:stCondLst>
+                                  <p:childTnLst>
+                                    <p:set>
+                                      <p:cBhvr>
+                                        <p:cTn id="11" dur="1" fill="hold">
                                           <p:stCondLst>
                                             <p:cond delay="0"/>
                                           </p:stCondLst>
@@ -16460,7 +17116,7 @@
                                     </p:set>
                                     <p:animEffect transition="in" filter="fade">
                                       <p:cBhvr>
-                                        <p:cTn id="7" dur="300"/>
+                                        <p:cTn id="12" dur="300"/>
                                         <p:tgtEl>
                                           <p:spTgt spid="8"/>
                                         </p:tgtEl>
@@ -16473,20 +17129,20 @@
                           </p:cTn>
                         </p:par>
                         <p:par>
-                          <p:cTn id="8" fill="hold">
+                          <p:cTn id="13" fill="hold">
                             <p:stCondLst>
-                              <p:cond delay="300"/>
+                              <p:cond delay="1400"/>
                             </p:stCondLst>
                             <p:childTnLst>
                               <p:par>
-                                <p:cTn xmlns:p="http://schemas.openxmlformats.org/presentationml/2006/main" id="9" presetID="51" presetClass="path" presetSubtype="0" accel="50000" decel="50000" fill="hold" grpId="0" nodeType="afterEffect">
+                                <p:cTn xmlns:p="http://schemas.openxmlformats.org/presentationml/2006/main" id="14" presetID="51" presetClass="path" presetSubtype="0" accel="50000" decel="50000" fill="hold" grpId="0" nodeType="afterEffect">
                                   <p:stCondLst>
                                     <p:cond delay="500"/>
                                   </p:stCondLst>
                                   <p:childTnLst>
                                     <p:animMotion origin="layout" path="M 0 0 L -0.04 0.067 C -0.049 0.081 -0.054 0.102 -0.054 0.124 C -0.054 0.149 -0.049 0.169 -0.04 0.183 L 0 0.25 E" pathEditMode="relative" ptsTypes="">
                                       <p:cBhvr>
-                                        <p:cTn id="10" dur="2400" fill="hold"/>
+                                        <p:cTn id="15" dur="2400" fill="hold"/>
                                         <p:tgtEl>
                                           <p:spTgt spid="8"/>
                                         </p:tgtEl>
@@ -17587,6 +18243,130 @@
   <p:transition xmlns:p14="http://schemas.microsoft.com/office/powerpoint/2010/main" p14:dur="400">
     <p:fade/>
   </p:transition>
+  <p:timing>
+    <p:tnLst>
+      <p:par>
+        <p:cTn id="1" dur="indefinite" restart="never" nodeType="tmRoot">
+          <p:childTnLst>
+            <p:seq concurrent="1" nextAc="seek">
+              <p:cTn id="2" dur="indefinite" nodeType="mainSeq">
+                <p:childTnLst>
+                  <p:par>
+                    <p:cTn id="3" fill="hold">
+                      <p:stCondLst>
+                        <p:cond delay="indefinite"/>
+                        <p:cond evt="onBegin" delay="0">
+                          <p:tn val="2"/>
+                        </p:cond>
+                      </p:stCondLst>
+                      <p:childTnLst>
+                        <p:par>
+                          <p:cTn id="4" fill="hold">
+                            <p:stCondLst>
+                              <p:cond delay="0"/>
+                            </p:stCondLst>
+                            <p:childTnLst>
+                              <p:par>
+                                <p:cTn xmlns:p="http://schemas.openxmlformats.org/presentationml/2006/main" id="5" presetID="23" presetClass="entr" presetSubtype="16" fill="hold" grpId="0" nodeType="afterEffect">
+                                  <p:stCondLst>
+                                    <p:cond delay="0"/>
+                                  </p:stCondLst>
+                                  <p:childTnLst>
+                                    <p:set>
+                                      <p:cBhvr>
+                                        <p:cTn id="6" dur="1" fill="hold">
+                                          <p:stCondLst>
+                                            <p:cond delay="0"/>
+                                          </p:stCondLst>
+                                        </p:cTn>
+                                        <p:tgtEl>
+                                          <p:spTgt spid="14"/>
+                                        </p:tgtEl>
+                                        <p:attrNameLst>
+                                          <p:attrName>style.visibility</p:attrName>
+                                        </p:attrNameLst>
+                                      </p:cBhvr>
+                                      <p:to>
+                                        <p:strVal val="visible"/>
+                                      </p:to>
+                                    </p:set>
+                                    <p:anim calcmode="lin" valueType="num">
+                                      <p:cBhvr>
+                                        <p:cTn id="7" dur="600" fill="hold"/>
+                                        <p:tgtEl>
+                                          <p:spTgt spid="14"/>
+                                        </p:tgtEl>
+                                        <p:attrNameLst>
+                                          <p:attrName>ppt_w</p:attrName>
+                                        </p:attrNameLst>
+                                      </p:cBhvr>
+                                      <p:tavLst>
+                                        <p:tav tm="0">
+                                          <p:val>
+                                            <p:fltVal val="0"/>
+                                          </p:val>
+                                        </p:tav>
+                                        <p:tav tm="100000">
+                                          <p:val>
+                                            <p:strVal val="#ppt_w"/>
+                                          </p:val>
+                                        </p:tav>
+                                      </p:tavLst>
+                                    </p:anim>
+                                    <p:anim calcmode="lin" valueType="num">
+                                      <p:cBhvr>
+                                        <p:cTn id="8" dur="600" fill="hold"/>
+                                        <p:tgtEl>
+                                          <p:spTgt spid="14"/>
+                                        </p:tgtEl>
+                                        <p:attrNameLst>
+                                          <p:attrName>ppt_h</p:attrName>
+                                        </p:attrNameLst>
+                                      </p:cBhvr>
+                                      <p:tavLst>
+                                        <p:tav tm="0">
+                                          <p:val>
+                                            <p:fltVal val="0"/>
+                                          </p:val>
+                                        </p:tav>
+                                        <p:tav tm="100000">
+                                          <p:val>
+                                            <p:strVal val="#ppt_h"/>
+                                          </p:val>
+                                        </p:tav>
+                                      </p:tavLst>
+                                    </p:anim>
+                                  </p:childTnLst>
+                                </p:cTn>
+                              </p:par>
+                            </p:childTnLst>
+                          </p:cTn>
+                        </p:par>
+                      </p:childTnLst>
+                    </p:cTn>
+                  </p:par>
+                </p:childTnLst>
+              </p:cTn>
+              <p:prevCondLst>
+                <p:cond evt="onPrev" delay="0">
+                  <p:tgtEl>
+                    <p:sldTgt/>
+                  </p:tgtEl>
+                </p:cond>
+              </p:prevCondLst>
+              <p:nextCondLst>
+                <p:cond evt="onNext" delay="0">
+                  <p:tgtEl>
+                    <p:sldTgt/>
+                  </p:tgtEl>
+                </p:cond>
+              </p:nextCondLst>
+            </p:seq>
+          </p:childTnLst>
+        </p:cTn>
+      </p:par>
+    </p:tnLst>
+  </p:timing>
 </p:sld>
 </file>
 

</xml_diff>